<commit_message>
Track showcase artifacts and update CLAUDE.md
- Add showcase slide deck and Word version of the paper
- Add TikZ lifecycle diagram preview file (scaffolding for Fig 1)
- CLAUDE.md: add Related KB section, GitHub repo distinction,
  top people, and useful query_graph queries
- Gitignore .claude/settings.local.json (per-user)

Co-Authored-By: Claude Opus 4.7 (1M context) <noreply@anthropic.com>
</commit_message>
<xml_diff>
--- a/Diotima Compliance Grade-AI.pptx
+++ b/Diotima Compliance Grade-AI.pptx
@@ -119,6 +119,11 @@
       </a:defRPr>
     </a:lvl9pPr>
   </p:defaultTextStyle>
+  <p:extLst>
+    <p:ext uri="{EFAFB233-063F-42B5-8137-9DF3F51BA10A}">
+      <p15:sldGuideLst xmlns:p15="http://schemas.microsoft.com/office/powerpoint/2012/main"/>
+    </p:ext>
+  </p:extLst>
 </p:presentation>
 </file>
 
@@ -212,7 +217,7 @@
           <a:p>
             <a:fld id="{60BAF1EA-ECD4-FA4B-946B-A572EFE76917}" type="datetimeFigureOut">
               <a:rPr lang="en-US" smtClean="0"/>
-              <a:t>3/14/26</a:t>
+              <a:t>5/4/26</a:t>
             </a:fld>
             <a:endParaRPr lang="en-US"/>
           </a:p>
@@ -1028,7 +1033,7 @@
           <a:p>
             <a:fld id="{6444479B-705B-4489-957E-7E8A228BDFA0}" type="datetime1">
               <a:rPr lang="en-US" smtClean="0"/>
-              <a:t>3/14/26</a:t>
+              <a:t>5/4/26</a:t>
             </a:fld>
             <a:endParaRPr lang="en-US"/>
           </a:p>
@@ -1228,7 +1233,7 @@
           <a:p>
             <a:fld id="{C07B66AD-7C08-490A-ADA4-B47E10FB2407}" type="datetime1">
               <a:rPr lang="en-US" smtClean="0"/>
-              <a:t>3/14/26</a:t>
+              <a:t>5/4/26</a:t>
             </a:fld>
             <a:endParaRPr lang="en-US"/>
           </a:p>
@@ -1487,7 +1492,7 @@
           <a:p>
             <a:fld id="{05B95027-4255-49E7-9841-CD21BCC99996}" type="datetime1">
               <a:rPr lang="en-US" smtClean="0"/>
-              <a:t>3/14/26</a:t>
+              <a:t>5/4/26</a:t>
             </a:fld>
             <a:endParaRPr lang="en-US"/>
           </a:p>
@@ -1728,7 +1733,7 @@
           <a:p>
             <a:fld id="{9F89F774-3FA6-43B8-9241-99959C8FD463}" type="datetime1">
               <a:rPr lang="en-US" smtClean="0"/>
-              <a:t>3/14/26</a:t>
+              <a:t>5/4/26</a:t>
             </a:fld>
             <a:endParaRPr lang="en-US"/>
           </a:p>
@@ -2055,7 +2060,7 @@
           <a:p>
             <a:fld id="{F9504452-5DCC-4FE2-A5C9-8A5EF6714D65}" type="datetime1">
               <a:rPr lang="en-US" smtClean="0"/>
-              <a:t>3/14/26</a:t>
+              <a:t>5/4/26</a:t>
             </a:fld>
             <a:endParaRPr lang="en-US"/>
           </a:p>
@@ -2365,7 +2370,7 @@
           <a:p>
             <a:fld id="{E579ABC2-0180-4F3A-A895-A85BC724D472}" type="datetime1">
               <a:rPr lang="en-US" smtClean="0"/>
-              <a:t>3/14/26</a:t>
+              <a:t>5/4/26</a:t>
             </a:fld>
             <a:endParaRPr lang="en-US"/>
           </a:p>
@@ -2783,7 +2788,7 @@
           <a:p>
             <a:fld id="{6AEEA9BA-4E8F-439E-BEA4-91FBA01E3F5F}" type="datetime1">
               <a:rPr lang="en-US" smtClean="0"/>
-              <a:t>3/14/26</a:t>
+              <a:t>5/4/26</a:t>
             </a:fld>
             <a:endParaRPr lang="en-US"/>
           </a:p>
@@ -2925,7 +2930,7 @@
           <a:p>
             <a:fld id="{BE15BF18-0007-481C-AA29-413124BC3EE7}" type="datetime1">
               <a:rPr lang="en-US" smtClean="0"/>
-              <a:t>3/14/26</a:t>
+              <a:t>5/4/26</a:t>
             </a:fld>
             <a:endParaRPr lang="en-US"/>
           </a:p>
@@ -3087,7 +3092,7 @@
           <a:p>
             <a:fld id="{09BE9870-3748-43AD-B547-02A075CB4A1D}" type="datetime1">
               <a:rPr lang="en-US" smtClean="0"/>
-              <a:t>3/14/26</a:t>
+              <a:t>5/4/26</a:t>
             </a:fld>
             <a:endParaRPr lang="en-US"/>
           </a:p>
@@ -3404,7 +3409,7 @@
           <a:p>
             <a:fld id="{558E7897-33C5-4F1A-9307-D068E37F3DC7}" type="datetime1">
               <a:rPr lang="en-US" smtClean="0"/>
-              <a:t>3/14/26</a:t>
+              <a:t>5/4/26</a:t>
             </a:fld>
             <a:endParaRPr lang="en-US"/>
           </a:p>
@@ -3699,7 +3704,7 @@
           <a:p>
             <a:fld id="{82E171BA-CC09-47C8-A6DF-F5C5CB59CEEC}" type="datetime1">
               <a:rPr lang="en-US" smtClean="0"/>
-              <a:t>3/14/26</a:t>
+              <a:t>5/4/26</a:t>
             </a:fld>
             <a:endParaRPr lang="en-US"/>
           </a:p>
@@ -3940,7 +3945,7 @@
           <a:p>
             <a:fld id="{7DA38F49-B3E2-4BF0-BEC7-C30D34ABBB8D}" type="datetime1">
               <a:rPr lang="en-US" smtClean="0"/>
-              <a:t>3/14/26</a:t>
+              <a:t>5/4/26</a:t>
             </a:fld>
             <a:endParaRPr lang="en-US"/>
           </a:p>
@@ -18118,6 +18123,7 @@
   </we:alternateReferences>
   <we:properties>
     <we:property name="Office.AutoShowTaskpaneWithDocument" value="true"/>
+    <we:property name="claude.fileId" value="&quot;afa2a7fd-6ae3-4501-80e9-4f56be42280c&quot;"/>
   </we:properties>
   <we:bindings/>
   <we:snapshot xmlns:r="http://schemas.openxmlformats.org/officeDocument/2006/relationships"/>

</xml_diff>